<commit_message>
Uncertainty: report CRPS and spread/RMSE only, with the standard RMS spread
- Spread is now sqrt(mean sigma^2), the usual ensemble definition (a calibrated
  forecast has spread = RMSE); it was mean(sigma), which is systematically lower
  when sigma varies across cells.
- CRPS replaces CRPS skill; the constant-sigma reference and calibration.csv
  (interval coverage) are dropped. uncertainty.csv: rmse, spread, spread_rmse, crps,
  with day-bootstrap intervals for crps and spread_rmse.
- Rescored the seven test days (no model rerun of the EnKF). CRPS unchanged:
  DINCAE 0.074, 4DVarNet aug. head 0.106, EnKF 0.115. Spread/RMSE: DINCAE
  0.58 -> 0.89, 4DVarNet 0.66 -> 1.30 (velocity variance 3.29), EnKF 1.01 -> 1.38.
- Original vs final EnKF: CRPS 0.161 -> 0.115, spread/RMSE 0.014 -> 1.38.
- README, EnKF README, supervisor README, PROJECT_OVERVIEW and the deck updated.

Co-Authored-By: Claude Opus 5.5 <noreply@anthropic.com>
</commit_message>
<xml_diff>
--- a/slides/enkf_optimisation.pptx
+++ b/slides/enkf_optimisation.pptx
@@ -948,7 +948,7 @@
           <a:p>
             <a:r>
               <a:rPr lang="en-US" dirty="0"/>
-              <a:t>Both filters run through the same code on the same observations and are scored exactly as in the six-method comparison. The uncertainty goes from unusable to usable: spread from 1% of the error to about 1.0 times it, and CRPS skill from negative, worse than a constant sigma, to positive. Pooled RMSE is slightly lower than the original; velocity variance is still somewhat worse.</a:t>
+              <a:t>Both filters run through the same code on the same observations and are scored exactly as in the six-method comparison. The uncertainty goes from unusable to usable: spread from about 1% of the error to 1.4 times it, now somewhat too wide, mostly on the velocity channels; CRPS about 29% lower. Pooled RMSE is slightly lower than the original; velocity variance is still somewhat worse.</a:t>
             </a:r>
             <a:endParaRPr lang="en-US" dirty="0"/>
           </a:p>
@@ -1606,7 +1606,7 @@
                 <a:ea typeface="Cambria" pitchFamily="34" charset="-122"/>
                 <a:cs typeface="Cambria" pitchFamily="34" charset="-120"/>
               </a:rPr>
-              <a:t>0.0025</a:t>
+              <a:t>0.0036</a:t>
             </a:r>
             <a:endParaRPr lang="en-US" sz="3600" dirty="0"/>
           </a:p>
@@ -1684,7 +1684,7 @@
                 <a:ea typeface="Cambria" pitchFamily="34" charset="-122"/>
                 <a:cs typeface="Cambria" pitchFamily="34" charset="-120"/>
               </a:rPr>
-              <a:t>0.24</a:t>
+              <a:t>0.26</a:t>
             </a:r>
             <a:endParaRPr lang="en-US" sz="3600" dirty="0"/>
           </a:p>
@@ -1821,7 +1821,7 @@
                 <a:ea typeface="Calibri" pitchFamily="34" charset="-122"/>
                 <a:cs typeface="Calibri" pitchFamily="34" charset="-120"/>
               </a:rPr>
-              <a:t>Original configuration, test days.</a:t>
+              <a:t>Original configuration; seven test days, unobserved walkable cells; spread = RMS ensemble spread.</a:t>
             </a:r>
             <a:endParaRPr lang="en-US" sz="850" dirty="0"/>
           </a:p>
@@ -8306,7 +8306,7 @@
                           <a:ea typeface="Calibri" pitchFamily="34" charset="-122"/>
                           <a:cs typeface="Calibri" pitchFamily="34" charset="-120"/>
                         </a:rPr>
-                        <a:t>0.010</a:t>
+                        <a:t>0.014</a:t>
                       </a:r>
                       <a:endParaRPr lang="en-US" sz="1150" dirty="0">
                         <a:latin typeface="Calibri" charset="0"/>
@@ -8374,7 +8374,7 @@
                           <a:ea typeface="Calibri" pitchFamily="34" charset="-122"/>
                           <a:cs typeface="Calibri" pitchFamily="34" charset="-120"/>
                         </a:rPr>
-                        <a:t>1.008</a:t>
+                        <a:t>1.381</a:t>
                       </a:r>
                       <a:endParaRPr lang="en-US" sz="1150" dirty="0">
                         <a:latin typeface="Calibri" charset="0"/>
@@ -8512,7 +8512,7 @@
                           <a:ea typeface="Calibri" pitchFamily="34" charset="-122"/>
                           <a:cs typeface="Calibri" pitchFamily="34" charset="-120"/>
                         </a:rPr>
-                        <a:t>CRPS skill (higher is better)</a:t>
+                        <a:t>CRPS (lower is better)</a:t>
                       </a:r>
                       <a:endParaRPr lang="en-US" sz="1150" dirty="0">
                         <a:latin typeface="Calibri" charset="0"/>
@@ -8580,7 +8580,7 @@
                           <a:ea typeface="Calibri" pitchFamily="34" charset="-122"/>
                           <a:cs typeface="Calibri" pitchFamily="34" charset="-120"/>
                         </a:rPr>
-                        <a:t>-0.252</a:t>
+                        <a:t>0.161</a:t>
                       </a:r>
                       <a:endParaRPr lang="en-US" sz="1150" dirty="0">
                         <a:latin typeface="Calibri" charset="0"/>
@@ -8648,7 +8648,7 @@
                           <a:ea typeface="Calibri" pitchFamily="34" charset="-122"/>
                           <a:cs typeface="Calibri" pitchFamily="34" charset="-120"/>
                         </a:rPr>
-                        <a:t>0.113</a:t>
+                        <a:t>0.115</a:t>
                       </a:r>
                       <a:endParaRPr lang="en-US" sz="1150" dirty="0">
                         <a:latin typeface="Calibri" charset="0"/>
@@ -8716,7 +8716,7 @@
                           <a:ea typeface="Calibri" pitchFamily="34" charset="-122"/>
                           <a:cs typeface="Calibri" pitchFamily="34" charset="-120"/>
                         </a:rPr>
-                        <a:t>&gt; 0</a:t>
+                        <a:t>—</a:t>
                       </a:r>
                       <a:endParaRPr lang="en-US" sz="1150" dirty="0">
                         <a:latin typeface="Calibri" charset="0"/>
@@ -8826,7 +8826,7 @@
                 <a:ea typeface="Calibri" pitchFamily="34" charset="-122"/>
                 <a:cs typeface="Calibri" pitchFamily="34" charset="-120"/>
               </a:rPr>
-              <a:t>Spread from 1% of the error to 1.01×.</a:t>
+              <a:t>Spread from 1% of the error to 1.38× (now somewhat too wide); CRPS 29% lower.</a:t>
             </a:r>
             <a:endParaRPr lang="en-US" sz="1300" dirty="0"/>
           </a:p>
@@ -8903,7 +8903,7 @@
                 <a:ea typeface="Calibri" pitchFamily="34" charset="-122"/>
                 <a:cs typeface="Calibri" pitchFamily="34" charset="-120"/>
               </a:rPr>
-              <a:t>Seven test days, unobserved walkable cells, four channels; same code, observations and scoring for both.</a:t>
+              <a:t>Seven test days, unobserved walkable cells, four channels; spread = RMS ensemble spread; same code, observations and scoring for both.</a:t>
             </a:r>
             <a:endParaRPr lang="en-US" sz="850" dirty="0"/>
           </a:p>

</xml_diff>